<commit_message>
Tighten sync to ~0.55s, fix leak-chart labels on deck slide 8
- assemble.py: raise time-stretch cap 1.30->1.40, tighten breath gap;
  max audio/scene drift drops from ~1.1s to 0.55s (ml) / 0.57s (te)
- Pitch_Deck.pptx: bake explicit category labels under the leak-rate bars
- QC_RESULTS: update drift figures
</commit_message>
<xml_diff>
--- a/Pitch_Deck.pptx
+++ b/Pitch_Deck.pptx
@@ -157,7 +157,7 @@
               <a:lstStyle/>
               <a:p>
                 <a:pPr>
-                  <a:defRPr b="1" i="0" strike="noStrike" sz="1300" u="none">
+                  <a:defRPr b="1" i="0" strike="noStrike" sz="1500" u="none">
                     <a:solidFill>
                       <a:srgbClr val="FFFFFF"/>
                     </a:solidFill>
@@ -219,7 +219,7 @@
             <a:lstStyle/>
             <a:p>
               <a:pPr>
-                <a:defRPr b="1" i="0" strike="noStrike" sz="1300" u="none">
+                <a:defRPr b="1" i="0" strike="noStrike" sz="1500" u="none">
                   <a:solidFill>
                     <a:srgbClr val="FFFFFF"/>
                   </a:solidFill>
@@ -236,7 +236,7 @@
           <c:showBubbleSize val="0"/>
           <c:showLeaderLines val="0"/>
         </c:dLbls>
-        <c:gapWidth val="60"/>
+        <c:gapWidth val="55"/>
         <c:overlap val="0"/>
         <c:axId val="2094734554"/>
         <c:axId val="2094734552"/>
@@ -247,7 +247,7 @@
         <c:scaling>
           <c:orientation val="minMax"/>
         </c:scaling>
-        <c:delete val="0"/>
+        <c:delete val="1"/>
         <c:axPos val="b"/>
         <c:numFmt formatCode="General" sourceLinked="1"/>
         <c:majorTickMark val="out"/>
@@ -269,7 +269,7 @@
             <a:pPr>
               <a:defRPr sz="1200" b="0" i="0" u="none" strike="noStrike">
                 <a:solidFill>
-                  <a:srgbClr val="CFE0C9"/>
+                  <a:srgbClr val="000000"/>
                 </a:solidFill>
                 <a:latin typeface="Arial"/>
               </a:defRPr>
@@ -742,7 +742,7 @@
           <a:p>
             <a:r>
               <a:rPr lang="en-US" dirty="0"/>
-              <a:t>Framing: this is a reach problem, and it lives squarely in AI. We can put the channel in front of ~190M people it's invisible to today — in the creator's own voice, for zero rupees.</a:t>
+              <a:t>Framing: a reach problem that lives in AI. We can put the channel in front of ~190M people it's invisible to today — in the creator's own voice, for zero rupees.</a:t>
             </a:r>
             <a:endParaRPr lang="en-US" dirty="0"/>
           </a:p>
@@ -830,7 +830,7 @@
           <a:p>
             <a:r>
               <a:rPr lang="en-US" dirty="0"/>
-              <a:t>This is the CEO slide: it's a system, not a stunt. The economics invert nicely — compute is trivial, and the money goes to human quality, which is the right place for a wellness brand.</a:t>
+              <a:t>The CEO slide: it's a system, not a stunt. Compute is trivial; money goes to human quality — the right place for a wellness brand.</a:t>
             </a:r>
             <a:endParaRPr lang="en-US" dirty="0"/>
           </a:p>
@@ -918,7 +918,7 @@
           <a:p>
             <a:r>
               <a:rPr lang="en-US" dirty="0"/>
-              <a:t>Close on confidence: the hard part (a working, verified, free system) is done. What remains is judgment calls the brand owns — review, sequencing, and consent.</a:t>
+              <a:t>Close on confidence: the hard part — a working, verified, free system — is done. What remains is judgment the brand owns: review, sequencing, consent.</a:t>
             </a:r>
             <a:endParaRPr lang="en-US" dirty="0"/>
           </a:p>
@@ -1006,7 +1006,7 @@
           <a:p>
             <a:r>
               <a:rPr lang="en-US" dirty="0"/>
-              <a:t>This isn't a content problem — the content already performs. It's a language-access problem, and it's the cheapest reach we'll ever buy.</a:t>
+              <a:t>Not a content problem — the content already performs. A language-access problem, and the cheapest reach we'll ever buy.</a:t>
             </a:r>
             <a:endParaRPr lang="en-US" dirty="0"/>
           </a:p>
@@ -1094,7 +1094,7 @@
           <a:p>
             <a:r>
               <a:rPr lang="en-US" dirty="0"/>
-              <a:t>The strategic point: this is an open door. Free tools can't walk through it, so being early here is a durable edge — and trust in a health channel lives in the creator's voice.</a:t>
+              <a:t>This is an open door. Free tools can't walk through it, so being early is a durable edge — and trust in a health channel lives in the creator's voice.</a:t>
             </a:r>
             <a:endParaRPr lang="en-US" dirty="0"/>
           </a:p>
@@ -1182,7 +1182,7 @@
           <a:p>
             <a:r>
               <a:rPr lang="en-US" dirty="0"/>
-              <a:t>Lead with the proof. Concrete, verified, and free. Everything after this is how we got here and how it scales.</a:t>
+              <a:t>Lead with the proof: concrete, verified, free. Everything after is how we got here and how it scales.</a:t>
             </a:r>
             <a:endParaRPr lang="en-US" dirty="0"/>
           </a:p>
@@ -1270,7 +1270,7 @@
           <a:p>
             <a:r>
               <a:rPr lang="en-US" dirty="0"/>
-              <a:t>This is the whole system. Four stages, all free tools. The one deliberate choice: translation is a reviewable text artifact before we ever synthesize — because fixing a word after synthesis costs a re-render.</a:t>
+              <a:t>The whole system: four stages, all free tools. Translation is a reviewable text artifact before synthesis — fixing a word after synthesis costs a re-render.</a:t>
             </a:r>
             <a:endParaRPr lang="en-US" dirty="0"/>
           </a:p>
@@ -1358,7 +1358,7 @@
           <a:p>
             <a:r>
               <a:rPr lang="en-US" dirty="0"/>
-              <a:t>The honest decision path: the obvious winner was inaccessible, the premium option was expensive, and the right answer was India's own open-source model. The budget is insurance, not a bill.</a:t>
+              <a:t>The obvious winner was inaccessible, the premium option expensive, the right answer was India's own open-source model. The budget is insurance, not a bill.</a:t>
             </a:r>
             <a:endParaRPr lang="en-US" dirty="0"/>
           </a:p>
@@ -1446,7 +1446,7 @@
           <a:p>
             <a:r>
               <a:rPr lang="en-US" dirty="0"/>
-              <a:t>Verification is layered and cheapest-first. The point to land: we built the review kit so a native speaker can sign off in ~40 minutes, and that sign-off is non-negotiable for health content.</a:t>
+              <a:t>Verification is layered, cheapest-first. A native speaker can sign off in ~40 minutes, and that sign-off is non-negotiable for health content.</a:t>
             </a:r>
             <a:endParaRPr lang="en-US" dirty="0"/>
           </a:p>
@@ -1534,7 +1534,7 @@
           <a:p>
             <a:r>
               <a:rPr lang="en-US" dirty="0"/>
-              <a:t>Counter-intuitively, this is the most confidence-building slide. It shows the system has honest failure-detection and that we fix root causes, not symptoms. Final state: 0 leaks across 460 segments, verified with the right detector.</a:t>
+              <a:t>The most confidence-building slide: honest failure-detection, root-cause fixes. Final state: 0 leaks across 460 segments, verified with the right detector.</a:t>
             </a:r>
             <a:endParaRPr lang="en-US" dirty="0"/>
           </a:p>
@@ -1622,7 +1622,7 @@
           <a:p>
             <a:r>
               <a:rPr lang="en-US" dirty="0"/>
-              <a:t>The reframe for a CEO: we didn't spend the budget, we priced the downside. If native reviewers ever want more polish, the exact next step and its cost are already known.</a:t>
+              <a:t>For a CEO: we didn't spend the budget, we priced the downside. If reviewers want more polish, the next step and its cost are already known.</a:t>
             </a:r>
             <a:endParaRPr lang="en-US" dirty="0"/>
           </a:p>
@@ -3237,7 +3237,7 @@
                 <a:ea typeface="Calibri" pitchFamily="34" charset="-122"/>
                 <a:cs typeface="Calibri" pitchFamily="34" charset="-120"/>
               </a:rPr>
-              <a:t>One GPU collapses synthesis to minutes. The real cost is native review (~₹2–3k/video) — exactly where a health channel should spend.</a:t>
+              <a:t>One GPU collapses synthesis to minutes. The real cost is native review (~₹2–3k/video) — where a health channel should spend.</a:t>
             </a:r>
             <a:endParaRPr lang="en-US" sz="1250" dirty="0"/>
           </a:p>
@@ -8578,27 +8578,7 @@
       </p:sp>
       <p:sp>
         <p:nvSpPr>
-          <p:cNvPr id="24" name="Shape 22"/>
-          <p:cNvSpPr/>
-          <p:nvPr/>
-        </p:nvSpPr>
-        <p:spPr>
-          <a:xfrm>
-            <a:off x="640080" y="6172200"/>
-            <a:ext cx="10881360" cy="914"/>
-          </a:xfrm>
-          <a:prstGeom prst="roundRect">
-            <a:avLst/>
-          </a:prstGeom>
-          <a:solidFill>
-            <a:srgbClr val="F7F5EF"/>
-          </a:solidFill>
-          <a:ln/>
-        </p:spPr>
-      </p:sp>
-      <p:sp>
-        <p:nvSpPr>
-          <p:cNvPr id="25" name="Text 23"/>
+          <p:cNvPr id="24" name="Text 22"/>
           <p:cNvSpPr/>
           <p:nvPr/>
         </p:nvSpPr>
@@ -8849,8 +8829,8 @@
         </p:nvSpPr>
         <p:spPr>
           <a:xfrm>
-            <a:off x="7040880" y="1965960"/>
-            <a:ext cx="4572000" cy="365760"/>
+            <a:off x="6949440" y="1965960"/>
+            <a:ext cx="4846320" cy="365760"/>
           </a:xfrm>
           <a:prstGeom prst="rect">
             <a:avLst/>
@@ -8874,7 +8854,7 @@
                 <a:ea typeface="Calibri" pitchFamily="34" charset="-122"/>
                 <a:cs typeface="Calibri" pitchFamily="34" charset="-120"/>
               </a:rPr>
-              <a:t>Reference-echo leak rate</a:t>
+              <a:t>Reference-echo leak rate (% of segments)</a:t>
             </a:r>
             <a:endParaRPr lang="en-US" sz="1300" dirty="0"/>
           </a:p>
@@ -8887,8 +8867,8 @@
           <p:nvPr/>
         </p:nvGraphicFramePr>
         <p:xfrm>
-          <a:off x="6949440" y="2286000"/>
-          <a:ext cx="4754880" cy="2834640"/>
+          <a:off x="6949440" y="2331720"/>
+          <a:ext cx="4754880" cy="1965960"/>
         </p:xfrm>
         <a:graphic xmlns:a="http://schemas.openxmlformats.org/drawingml/2006/main">
           <a:graphicData uri="http://schemas.openxmlformats.org/drawingml/2006/chart">
@@ -8898,7 +8878,124 @@
       </p:graphicFrame>
       <p:sp>
         <p:nvSpPr>
-          <p:cNvPr id="7" name="Shape 4"/>
+          <p:cNvPr id="7" name="Text 4"/>
+          <p:cNvSpPr/>
+          <p:nvPr/>
+        </p:nvSpPr>
+        <p:spPr>
+          <a:xfrm>
+            <a:off x="6903720" y="4334256"/>
+            <a:ext cx="1600200" cy="274320"/>
+          </a:xfrm>
+          <a:prstGeom prst="rect">
+            <a:avLst/>
+          </a:prstGeom>
+          <a:noFill/>
+          <a:ln/>
+        </p:spPr>
+        <p:txBody>
+          <a:bodyPr wrap="square" lIns="0" tIns="0" rIns="0" bIns="0" rtlCol="0" anchor="ctr"/>
+          <a:lstStyle/>
+          <a:p>
+            <a:pPr algn="ctr" indent="0" marL="0">
+              <a:buNone/>
+            </a:pPr>
+            <a:r>
+              <a:rPr lang="en-US" sz="1150" b="1" dirty="0">
+                <a:solidFill>
+                  <a:srgbClr val="8FB06B"/>
+                </a:solidFill>
+                <a:latin typeface="Calibri" pitchFamily="34" charset="0"/>
+                <a:ea typeface="Calibri" pitchFamily="34" charset="-122"/>
+                <a:cs typeface="Calibri" pitchFamily="34" charset="-120"/>
+              </a:rPr>
+              <a:t>bad reference</a:t>
+            </a:r>
+            <a:endParaRPr lang="en-US" sz="1150" dirty="0"/>
+          </a:p>
+        </p:txBody>
+      </p:sp>
+      <p:sp>
+        <p:nvSpPr>
+          <p:cNvPr id="8" name="Text 5"/>
+          <p:cNvSpPr/>
+          <p:nvPr/>
+        </p:nvSpPr>
+        <p:spPr>
+          <a:xfrm>
+            <a:off x="8549640" y="4334256"/>
+            <a:ext cx="1600200" cy="274320"/>
+          </a:xfrm>
+          <a:prstGeom prst="rect">
+            <a:avLst/>
+          </a:prstGeom>
+          <a:noFill/>
+          <a:ln/>
+        </p:spPr>
+        <p:txBody>
+          <a:bodyPr wrap="square" lIns="0" tIns="0" rIns="0" bIns="0" rtlCol="0" anchor="ctr"/>
+          <a:lstStyle/>
+          <a:p>
+            <a:pPr algn="ctr" indent="0" marL="0">
+              <a:buNone/>
+            </a:pPr>
+            <a:r>
+              <a:rPr lang="en-US" sz="1150" b="1" dirty="0">
+                <a:solidFill>
+                  <a:srgbClr val="8FB06B"/>
+                </a:solidFill>
+                <a:latin typeface="Calibri" pitchFamily="34" charset="0"/>
+                <a:ea typeface="Calibri" pitchFamily="34" charset="-122"/>
+                <a:cs typeface="Calibri" pitchFamily="34" charset="-120"/>
+              </a:rPr>
+              <a:t>clean reference</a:t>
+            </a:r>
+            <a:endParaRPr lang="en-US" sz="1150" dirty="0"/>
+          </a:p>
+        </p:txBody>
+      </p:sp>
+      <p:sp>
+        <p:nvSpPr>
+          <p:cNvPr id="9" name="Text 6"/>
+          <p:cNvSpPr/>
+          <p:nvPr/>
+        </p:nvSpPr>
+        <p:spPr>
+          <a:xfrm>
+            <a:off x="10104120" y="4334256"/>
+            <a:ext cx="1600200" cy="274320"/>
+          </a:xfrm>
+          <a:prstGeom prst="rect">
+            <a:avLst/>
+          </a:prstGeom>
+          <a:noFill/>
+          <a:ln/>
+        </p:spPr>
+        <p:txBody>
+          <a:bodyPr wrap="square" lIns="0" tIns="0" rIns="0" bIns="0" rtlCol="0" anchor="ctr"/>
+          <a:lstStyle/>
+          <a:p>
+            <a:pPr algn="ctr" indent="0" marL="0">
+              <a:buNone/>
+            </a:pPr>
+            <a:r>
+              <a:rPr lang="en-US" sz="1150" b="1" dirty="0">
+                <a:solidFill>
+                  <a:srgbClr val="8FB06B"/>
+                </a:solidFill>
+                <a:latin typeface="Calibri" pitchFamily="34" charset="0"/>
+                <a:ea typeface="Calibri" pitchFamily="34" charset="-122"/>
+                <a:cs typeface="Calibri" pitchFamily="34" charset="-120"/>
+              </a:rPr>
+              <a:t>after trim</a:t>
+            </a:r>
+            <a:endParaRPr lang="en-US" sz="1150" dirty="0"/>
+          </a:p>
+        </p:txBody>
+      </p:sp>
+      <p:sp>
+        <p:nvSpPr>
+          <p:cNvPr id="10" name="Shape 7"/>
           <p:cNvSpPr/>
           <p:nvPr/>
         </p:nvSpPr>
@@ -8920,7 +9017,7 @@
       </p:sp>
       <p:sp>
         <p:nvSpPr>
-          <p:cNvPr id="8" name="Text 5"/>
+          <p:cNvPr id="11" name="Text 8"/>
           <p:cNvSpPr/>
           <p:nvPr/>
         </p:nvSpPr>

</xml_diff>